<commit_message>
lab: deck uses a real app screenshot, Tidalith art for the locks, four-and-three stats; cards say the command centre is the only screen
Co-Authored-By: Claude Fable 5.1 <noreply@anthropic.com>
</commit_message>
<xml_diff>
--- a/lab/kaiju-lab-intro.pptx
+++ b/lab/kaiju-lab-intro.pptx
@@ -115,27 +115,27 @@
   <p:extLst>
     <p:ext uri="{521415D9-36F7-43E2-AB2F-B90AF26B5E84}">
       <p14:sectionLst xmlns:p14="http://schemas.microsoft.com/office/powerpoint/2010/main">
-        <p14:section name="Introduction" id="{4f70035f-3289-7dad-b535-b48906f57aa5}">
+        <p14:section name="Introduction" id="{d26927e4-7996-eb2f-96ec-18a607b5c8f7}">
           <p14:sldIdLst>
             <p14:sldId id="256"/>
             <p14:sldId id="257"/>
             <p14:sldId id="258"/>
           </p14:sldIdLst>
         </p14:section>
-        <p14:section name="Your scenario and role" id="{9457b487-b895-1fb7-d205-9b9149fecb06}">
+        <p14:section name="Your scenario and role" id="{f329bf95-b873-7f02-958c-c1e9d99ee267}">
           <p14:sldIdLst>
             <p14:sldId id="259"/>
             <p14:sldId id="260"/>
           </p14:sldIdLst>
         </p14:section>
-        <p14:section name="The labs" id="{ebff8525-52a9-3584-b572-de5e62434b3f}">
+        <p14:section name="The labs" id="{29baba16-acdf-b9ee-91f1-d2c512b67875}">
           <p14:sldIdLst>
             <p14:sldId id="261"/>
             <p14:sldId id="262"/>
             <p14:sldId id="263"/>
           </p14:sldIdLst>
         </p14:section>
-        <p14:section name="Close" id="{a48e7703-e5a3-6492-8346-6f4fdd071118}">
+        <p14:section name="Close" id="{cb3b8aa6-6bd9-1b56-7696-66165a1ae593}">
           <p14:sldIdLst>
             <p14:sldId id="264"/>
           </p14:sldIdLst>
@@ -2231,7 +2231,7 @@
       </p:sp>
       <p:sp>
         <p:nvSpPr>
-          <p:cNvPr id="3" name="stat hour"/>
+          <p:cNvPr id="3" name="stat scenarios"/>
           <p:cNvSpPr txBox="1"/>
           <p:nvPr/>
         </p:nvSpPr>
@@ -2259,7 +2259,7 @@
                   <a:schemeClr val="accent2"/>
                 </a:solidFill>
               </a:rPr>
-              <a:t>1</a:t>
+              <a:t>4</a:t>
             </a:r>
             <a:endParaRPr lang="en-US" sz="6000" dirty="0"/>
           </a:p>
@@ -2267,7 +2267,7 @@
       </p:sp>
       <p:sp>
         <p:nvSpPr>
-          <p:cNvPr id="4" name="stat label hour"/>
+          <p:cNvPr id="4" name="stat label scenarios"/>
           <p:cNvSpPr txBox="1"/>
           <p:nvPr/>
         </p:nvSpPr>
@@ -2295,7 +2295,7 @@
                   <a:schemeClr val="accent5"/>
                 </a:solidFill>
               </a:rPr>
-              <a:t>hour</a:t>
+              <a:t>scenarios</a:t>
             </a:r>
             <a:endParaRPr lang="en-US" sz="1400" dirty="0"/>
           </a:p>
@@ -2309,7 +2309,7 @@
         </p:nvSpPr>
         <p:spPr>
           <a:xfrm>
-            <a:off x="2560320" y="1143000"/>
+            <a:off x="2926080" y="1143000"/>
             <a:ext cx="1828800" cy="914400"/>
           </a:xfrm>
           <a:prstGeom prst="rect">
@@ -2345,7 +2345,7 @@
         </p:nvSpPr>
         <p:spPr>
           <a:xfrm>
-            <a:off x="2560320" y="2011680"/>
+            <a:off x="2926080" y="2011680"/>
             <a:ext cx="1828800" cy="365760"/>
           </a:xfrm>
           <a:prstGeom prst="rect">
@@ -2375,151 +2375,7 @@
       </p:sp>
       <p:sp>
         <p:nvSpPr>
-          <p:cNvPr id="7" name="stat role"/>
-          <p:cNvSpPr txBox="1"/>
-          <p:nvPr/>
-        </p:nvSpPr>
-        <p:spPr>
-          <a:xfrm>
-            <a:off x="4572000" y="1143000"/>
-            <a:ext cx="1828800" cy="914400"/>
-          </a:xfrm>
-          <a:prstGeom prst="rect">
-            <a:avLst/>
-          </a:prstGeom>
-          <a:noFill/>
-          <a:ln/>
-        </p:spPr>
-        <p:txBody>
-          <a:bodyPr wrap="square" lIns="0" tIns="0" rIns="0" bIns="0" rtlCol="0" anchor="ctr"/>
-          <a:lstStyle/>
-          <a:p>
-            <a:pPr indent="0" marL="0">
-              <a:buNone/>
-            </a:pPr>
-            <a:r>
-              <a:rPr lang="en-US" sz="6000" b="1" dirty="0">
-                <a:solidFill>
-                  <a:schemeClr val="accent2"/>
-                </a:solidFill>
-              </a:rPr>
-              <a:t>1</a:t>
-            </a:r>
-            <a:endParaRPr lang="en-US" sz="6000" dirty="0"/>
-          </a:p>
-        </p:txBody>
-      </p:sp>
-      <p:sp>
-        <p:nvSpPr>
-          <p:cNvPr id="8" name="stat label role"/>
-          <p:cNvSpPr txBox="1"/>
-          <p:nvPr/>
-        </p:nvSpPr>
-        <p:spPr>
-          <a:xfrm>
-            <a:off x="4572000" y="2011680"/>
-            <a:ext cx="1828800" cy="365760"/>
-          </a:xfrm>
-          <a:prstGeom prst="rect">
-            <a:avLst/>
-          </a:prstGeom>
-          <a:noFill/>
-          <a:ln/>
-        </p:spPr>
-        <p:txBody>
-          <a:bodyPr wrap="square" lIns="0" tIns="0" rIns="0" bIns="0" rtlCol="0" anchor="ctr"/>
-          <a:lstStyle/>
-          <a:p>
-            <a:pPr indent="0" marL="0">
-              <a:buNone/>
-            </a:pPr>
-            <a:r>
-              <a:rPr lang="en-US" sz="1400" dirty="0">
-                <a:solidFill>
-                  <a:schemeClr val="accent5"/>
-                </a:solidFill>
-              </a:rPr>
-              <a:t>role</a:t>
-            </a:r>
-            <a:endParaRPr lang="en-US" sz="1400" dirty="0"/>
-          </a:p>
-        </p:txBody>
-      </p:sp>
-      <p:sp>
-        <p:nvSpPr>
-          <p:cNvPr id="9" name="stat scenarios"/>
-          <p:cNvSpPr txBox="1"/>
-          <p:nvPr/>
-        </p:nvSpPr>
-        <p:spPr>
-          <a:xfrm>
-            <a:off x="6583680" y="1143000"/>
-            <a:ext cx="1828800" cy="914400"/>
-          </a:xfrm>
-          <a:prstGeom prst="rect">
-            <a:avLst/>
-          </a:prstGeom>
-          <a:noFill/>
-          <a:ln/>
-        </p:spPr>
-        <p:txBody>
-          <a:bodyPr wrap="square" lIns="0" tIns="0" rIns="0" bIns="0" rtlCol="0" anchor="ctr"/>
-          <a:lstStyle/>
-          <a:p>
-            <a:pPr indent="0" marL="0">
-              <a:buNone/>
-            </a:pPr>
-            <a:r>
-              <a:rPr lang="en-US" sz="6000" b="1" dirty="0">
-                <a:solidFill>
-                  <a:schemeClr val="accent2"/>
-                </a:solidFill>
-              </a:rPr>
-              <a:t>4</a:t>
-            </a:r>
-            <a:endParaRPr lang="en-US" sz="6000" dirty="0"/>
-          </a:p>
-        </p:txBody>
-      </p:sp>
-      <p:sp>
-        <p:nvSpPr>
-          <p:cNvPr id="10" name="stat label scenarios"/>
-          <p:cNvSpPr txBox="1"/>
-          <p:nvPr/>
-        </p:nvSpPr>
-        <p:spPr>
-          <a:xfrm>
-            <a:off x="6583680" y="2011680"/>
-            <a:ext cx="1828800" cy="365760"/>
-          </a:xfrm>
-          <a:prstGeom prst="rect">
-            <a:avLst/>
-          </a:prstGeom>
-          <a:noFill/>
-          <a:ln/>
-        </p:spPr>
-        <p:txBody>
-          <a:bodyPr wrap="square" lIns="0" tIns="0" rIns="0" bIns="0" rtlCol="0" anchor="ctr"/>
-          <a:lstStyle/>
-          <a:p>
-            <a:pPr indent="0" marL="0">
-              <a:buNone/>
-            </a:pPr>
-            <a:r>
-              <a:rPr lang="en-US" sz="1400" dirty="0">
-                <a:solidFill>
-                  <a:schemeClr val="accent5"/>
-                </a:solidFill>
-              </a:rPr>
-              <a:t>scenarios</a:t>
-            </a:r>
-            <a:endParaRPr lang="en-US" sz="1400" dirty="0"/>
-          </a:p>
-        </p:txBody>
-      </p:sp>
-      <p:sp>
-        <p:nvSpPr>
-          <p:cNvPr id="11" name="row0 circle"/>
+          <p:cNvPr id="7" name="row0 circle"/>
           <p:cNvSpPr/>
           <p:nvPr/>
         </p:nvSpPr>
@@ -2544,7 +2400,7 @@
       </p:sp>
       <p:pic>
         <p:nvPicPr>
-          <p:cNvPr id="12" name="row0 icon" descr="preencoded.png">    </p:cNvPr>
+          <p:cNvPr id="8" name="row0 icon" descr="preencoded.png">    </p:cNvPr>
           <p:cNvPicPr>
             <a:picLocks noChangeAspect="1"/>
           </p:cNvPicPr>
@@ -2568,7 +2424,7 @@
       </p:pic>
       <p:sp>
         <p:nvSpPr>
-          <p:cNvPr id="13" name="row head 0"/>
+          <p:cNvPr id="9" name="row head 0"/>
           <p:cNvSpPr txBox="1"/>
           <p:nvPr/>
         </p:nvSpPr>
@@ -2604,7 +2460,7 @@
       </p:sp>
       <p:sp>
         <p:nvSpPr>
-          <p:cNvPr id="14" name="row body 0"/>
+          <p:cNvPr id="10" name="row body 0"/>
           <p:cNvSpPr txBox="1"/>
           <p:nvPr/>
         </p:nvSpPr>
@@ -2640,7 +2496,7 @@
       </p:sp>
       <p:sp>
         <p:nvSpPr>
-          <p:cNvPr id="15" name="row1 circle"/>
+          <p:cNvPr id="11" name="row1 circle"/>
           <p:cNvSpPr/>
           <p:nvPr/>
         </p:nvSpPr>
@@ -2665,7 +2521,7 @@
       </p:sp>
       <p:pic>
         <p:nvPicPr>
-          <p:cNvPr id="16" name="row1 icon" descr="preencoded.png">    </p:cNvPr>
+          <p:cNvPr id="12" name="row1 icon" descr="preencoded.png">    </p:cNvPr>
           <p:cNvPicPr>
             <a:picLocks noChangeAspect="1"/>
           </p:cNvPicPr>
@@ -2689,7 +2545,7 @@
       </p:pic>
       <p:sp>
         <p:nvSpPr>
-          <p:cNvPr id="17" name="row head 1"/>
+          <p:cNvPr id="13" name="row head 1"/>
           <p:cNvSpPr txBox="1"/>
           <p:nvPr/>
         </p:nvSpPr>
@@ -2725,7 +2581,7 @@
       </p:sp>
       <p:sp>
         <p:nvSpPr>
-          <p:cNvPr id="18" name="row body 1"/>
+          <p:cNvPr id="14" name="row body 1"/>
           <p:cNvSpPr txBox="1"/>
           <p:nvPr/>
         </p:nvSpPr>
@@ -2761,7 +2617,7 @@
       </p:sp>
       <p:sp>
         <p:nvSpPr>
-          <p:cNvPr id="19" name="row2 circle"/>
+          <p:cNvPr id="15" name="row2 circle"/>
           <p:cNvSpPr/>
           <p:nvPr/>
         </p:nvSpPr>
@@ -2786,7 +2642,7 @@
       </p:sp>
       <p:pic>
         <p:nvPicPr>
-          <p:cNvPr id="20" name="row2 icon" descr="preencoded.png">    </p:cNvPr>
+          <p:cNvPr id="16" name="row2 icon" descr="preencoded.png">    </p:cNvPr>
           <p:cNvPicPr>
             <a:picLocks noChangeAspect="1"/>
           </p:cNvPicPr>
@@ -2810,7 +2666,7 @@
       </p:pic>
       <p:sp>
         <p:nvSpPr>
-          <p:cNvPr id="21" name="row head 2"/>
+          <p:cNvPr id="17" name="row head 2"/>
           <p:cNvSpPr txBox="1"/>
           <p:nvPr/>
         </p:nvSpPr>
@@ -2846,7 +2702,7 @@
       </p:sp>
       <p:sp>
         <p:nvSpPr>
-          <p:cNvPr id="22" name="row body 2"/>
+          <p:cNvPr id="18" name="row body 2"/>
           <p:cNvSpPr txBox="1"/>
           <p:nvPr/>
         </p:nvSpPr>
@@ -2988,635 +2844,69 @@
           </a:p>
         </p:txBody>
       </p:sp>
-      <p:sp>
-        <p:nvSpPr>
-          <p:cNvPr id="3" name="app frame"/>
-          <p:cNvSpPr/>
-          <p:nvPr/>
-        </p:nvSpPr>
+      <p:pic>
+        <p:nvPicPr>
+          <p:cNvPr id="3" name="app screenshot" descr="preencoded.png">    </p:cNvPr>
+          <p:cNvPicPr>
+            <a:picLocks noChangeAspect="1"/>
+          </p:cNvPicPr>
+          <p:nvPr/>
+        </p:nvPicPr>
+        <p:blipFill>
+          <a:blip r:embed="rId1"/>
+          <a:stretch>
+            <a:fillRect/>
+          </a:stretch>
+        </p:blipFill>
         <p:spPr>
           <a:xfrm>
             <a:off x="548640" y="1188720"/>
-            <a:ext cx="5120640" cy="3291840"/>
-          </a:xfrm>
-          <a:prstGeom prst="roundRect">
-            <a:avLst>
-              <a:gd name="adj" fmla="val 2222"/>
-            </a:avLst>
-          </a:prstGeom>
-          <a:solidFill>
-            <a:srgbClr val="1B1F3B"/>
-          </a:solidFill>
-          <a:ln w="12700">
-            <a:solidFill>
-              <a:srgbClr val="1B1F3B"/>
-            </a:solidFill>
-            <a:prstDash val="solid"/>
-          </a:ln>
-        </p:spPr>
-      </p:sp>
-      <p:sp>
-        <p:nvSpPr>
-          <p:cNvPr id="4" name="roster panel"/>
-          <p:cNvSpPr/>
-          <p:nvPr/>
-        </p:nvSpPr>
-        <p:spPr>
-          <a:xfrm>
-            <a:off x="685800" y="1325880"/>
-            <a:ext cx="1143000" cy="3017520"/>
-          </a:xfrm>
-          <a:prstGeom prst="rect">
-            <a:avLst/>
-          </a:prstGeom>
-          <a:solidFill>
-            <a:srgbClr val="2E3466"/>
-          </a:solidFill>
-          <a:ln w="12700">
-            <a:solidFill>
-              <a:srgbClr val="2E3466"/>
-            </a:solidFill>
-            <a:prstDash val="solid"/>
-          </a:ln>
-        </p:spPr>
-      </p:sp>
-      <p:sp>
-        <p:nvSpPr>
-          <p:cNvPr id="5" name="roster text"/>
-          <p:cNvSpPr txBox="1"/>
-          <p:nvPr/>
-        </p:nvSpPr>
-        <p:spPr>
-          <a:xfrm>
-            <a:off x="685800" y="1325880"/>
-            <a:ext cx="1143000" cy="3017520"/>
-          </a:xfrm>
-          <a:prstGeom prst="rect">
-            <a:avLst/>
-          </a:prstGeom>
-          <a:noFill/>
-          <a:ln/>
-        </p:spPr>
-        <p:txBody>
-          <a:bodyPr wrap="square" lIns="76200" tIns="76200" rIns="76200" bIns="76200" rtlCol="0" anchor="t"/>
-          <a:lstStyle/>
-          <a:p>
-            <a:pPr indent="0" marL="0">
-              <a:buNone/>
-            </a:pPr>
-            <a:r>
-              <a:rPr lang="en-US" sz="800" dirty="0">
-                <a:solidFill>
-                  <a:srgbClr val="CADCFC"/>
-                </a:solidFill>
-              </a:rPr>
-              <a:t>LEVIATHAN ROSTER</a:t>
-            </a:r>
-            <a:endParaRPr lang="en-US" sz="800" dirty="0"/>
-          </a:p>
-          <a:p>
-            <a:pPr indent="0" marL="0">
-              <a:buNone/>
-            </a:pPr>
-            <a:endParaRPr lang="en-US" sz="800" dirty="0"/>
-          </a:p>
-          <a:p>
-            <a:pPr indent="0" marL="0">
-              <a:buNone/>
-            </a:pPr>
-            <a:r>
-              <a:rPr lang="en-US" sz="800" dirty="0">
-                <a:solidFill>
-                  <a:srgbClr val="CADCFC"/>
-                </a:solidFill>
-              </a:rPr>
-              <a:t>Gorathos</a:t>
-            </a:r>
-            <a:endParaRPr lang="en-US" sz="800" dirty="0"/>
-          </a:p>
-          <a:p>
-            <a:pPr indent="0" marL="0">
-              <a:buNone/>
-            </a:pPr>
-            <a:r>
-              <a:rPr lang="en-US" sz="800" dirty="0">
-                <a:solidFill>
-                  <a:srgbClr val="CADCFC"/>
-                </a:solidFill>
-              </a:rPr>
-              <a:t>Vespyra</a:t>
-            </a:r>
-            <a:endParaRPr lang="en-US" sz="800" dirty="0"/>
-          </a:p>
-          <a:p>
-            <a:pPr indent="0" marL="0">
-              <a:buNone/>
-            </a:pPr>
-            <a:r>
-              <a:rPr lang="en-US" sz="800" dirty="0">
-                <a:solidFill>
-                  <a:srgbClr val="CADCFC"/>
-                </a:solidFill>
-              </a:rPr>
-              <a:t>Terrakon</a:t>
-            </a:r>
-            <a:endParaRPr lang="en-US" sz="800" dirty="0"/>
-          </a:p>
-          <a:p>
-            <a:pPr indent="0" marL="0">
-              <a:buNone/>
-            </a:pPr>
-            <a:r>
-              <a:rPr lang="en-US" sz="800" dirty="0">
-                <a:solidFill>
-                  <a:srgbClr val="CADCFC"/>
-                </a:solidFill>
-              </a:rPr>
-              <a:t>Nyxmora</a:t>
-            </a:r>
-            <a:endParaRPr lang="en-US" sz="800" dirty="0"/>
-          </a:p>
-          <a:p>
-            <a:pPr indent="0" marL="0">
-              <a:buNone/>
-            </a:pPr>
-            <a:r>
-              <a:rPr lang="en-US" sz="800" dirty="0">
-                <a:solidFill>
-                  <a:srgbClr val="CADCFC"/>
-                </a:solidFill>
-              </a:rPr>
-              <a:t>Skarnyx</a:t>
-            </a:r>
-            <a:endParaRPr lang="en-US" sz="800" dirty="0"/>
-          </a:p>
-          <a:p>
-            <a:pPr indent="0" marL="0">
-              <a:buNone/>
-            </a:pPr>
-            <a:r>
-              <a:rPr lang="en-US" sz="800" dirty="0">
-                <a:solidFill>
-                  <a:srgbClr val="CADCFC"/>
-                </a:solidFill>
-              </a:rPr>
-              <a:t>Molvorak</a:t>
-            </a:r>
-            <a:endParaRPr lang="en-US" sz="800" dirty="0"/>
-          </a:p>
-        </p:txBody>
-      </p:sp>
-      <p:sp>
-        <p:nvSpPr>
-          <p:cNvPr id="6" name="map panel"/>
-          <p:cNvSpPr/>
-          <p:nvPr/>
-        </p:nvSpPr>
-        <p:spPr>
-          <a:xfrm>
-            <a:off x="1920240" y="1325880"/>
-            <a:ext cx="2514600" cy="2103120"/>
-          </a:xfrm>
-          <a:prstGeom prst="rect">
-            <a:avLst/>
-          </a:prstGeom>
-          <a:solidFill>
-            <a:srgbClr val="243055"/>
-          </a:solidFill>
-          <a:ln w="12700">
-            <a:solidFill>
-              <a:srgbClr val="243055"/>
-            </a:solidFill>
-            <a:prstDash val="solid"/>
-          </a:ln>
-        </p:spPr>
-      </p:sp>
-      <p:sp>
-        <p:nvSpPr>
-          <p:cNvPr id="7" name="map text"/>
-          <p:cNvSpPr txBox="1"/>
-          <p:nvPr/>
-        </p:nvSpPr>
-        <p:spPr>
-          <a:xfrm>
-            <a:off x="1920240" y="1325880"/>
-            <a:ext cx="2514600" cy="457200"/>
-          </a:xfrm>
-          <a:prstGeom prst="rect">
-            <a:avLst/>
-          </a:prstGeom>
-          <a:noFill/>
-          <a:ln/>
-        </p:spPr>
-        <p:txBody>
-          <a:bodyPr wrap="square" lIns="76200" tIns="76200" rIns="76200" bIns="76200" rtlCol="0" anchor="t"/>
-          <a:lstStyle/>
-          <a:p>
-            <a:pPr indent="0" marL="0">
-              <a:buNone/>
-            </a:pPr>
-            <a:r>
-              <a:rPr lang="en-US" sz="800" dirty="0">
-                <a:solidFill>
-                  <a:srgbClr val="CADCFC"/>
-                </a:solidFill>
-              </a:rPr>
-              <a:t>COMMAND MAP</a:t>
-            </a:r>
-            <a:endParaRPr lang="en-US" sz="800" dirty="0"/>
-          </a:p>
-          <a:p>
-            <a:pPr indent="0" marL="0">
-              <a:buNone/>
-            </a:pPr>
-            <a:r>
-              <a:rPr lang="en-US" sz="800" dirty="0">
-                <a:solidFill>
-                  <a:srgbClr val="CADCFC"/>
-                </a:solidFill>
-              </a:rPr>
-              <a:t>Puget Sound, six tracks</a:t>
-            </a:r>
-            <a:endParaRPr lang="en-US" sz="800" dirty="0"/>
-          </a:p>
-        </p:txBody>
-      </p:sp>
-      <p:sp>
-        <p:nvSpPr>
-          <p:cNvPr id="8" name="kaiju marker 0"/>
-          <p:cNvSpPr/>
-          <p:nvPr/>
-        </p:nvSpPr>
-        <p:spPr>
-          <a:xfrm>
-            <a:off x="2651760" y="2103120"/>
-            <a:ext cx="128016" cy="128016"/>
-          </a:xfrm>
-          <a:prstGeom prst="ellipse">
-            <a:avLst/>
-          </a:prstGeom>
-          <a:solidFill>
-            <a:srgbClr val="D64545"/>
-          </a:solidFill>
-          <a:ln w="12700">
-            <a:solidFill>
-              <a:srgbClr val="D64545"/>
-            </a:solidFill>
-            <a:prstDash val="solid"/>
-          </a:ln>
-        </p:spPr>
-      </p:sp>
-      <p:sp>
-        <p:nvSpPr>
-          <p:cNvPr id="9" name="kaiju marker 1"/>
-          <p:cNvSpPr/>
-          <p:nvPr/>
-        </p:nvSpPr>
-        <p:spPr>
-          <a:xfrm>
-            <a:off x="3474720" y="2651760"/>
-            <a:ext cx="128016" cy="128016"/>
-          </a:xfrm>
-          <a:prstGeom prst="ellipse">
-            <a:avLst/>
-          </a:prstGeom>
-          <a:solidFill>
-            <a:srgbClr val="D64545"/>
-          </a:solidFill>
-          <a:ln w="12700">
-            <a:solidFill>
-              <a:srgbClr val="D64545"/>
-            </a:solidFill>
-            <a:prstDash val="solid"/>
-          </a:ln>
-        </p:spPr>
-      </p:sp>
-      <p:sp>
-        <p:nvSpPr>
-          <p:cNvPr id="10" name="kaiju marker 2"/>
-          <p:cNvSpPr/>
-          <p:nvPr/>
-        </p:nvSpPr>
-        <p:spPr>
-          <a:xfrm>
-            <a:off x="2377440" y="2926080"/>
-            <a:ext cx="128016" cy="128016"/>
-          </a:xfrm>
-          <a:prstGeom prst="ellipse">
-            <a:avLst/>
-          </a:prstGeom>
-          <a:solidFill>
-            <a:srgbClr val="D64545"/>
-          </a:solidFill>
-          <a:ln w="12700">
-            <a:solidFill>
-              <a:srgbClr val="D64545"/>
-            </a:solidFill>
-            <a:prstDash val="solid"/>
-          </a:ln>
-        </p:spPr>
-      </p:sp>
-      <p:sp>
-        <p:nvSpPr>
-          <p:cNvPr id="11" name="kaiju marker 3"/>
-          <p:cNvSpPr/>
-          <p:nvPr/>
-        </p:nvSpPr>
-        <p:spPr>
-          <a:xfrm>
-            <a:off x="3840480" y="2011680"/>
-            <a:ext cx="128016" cy="128016"/>
-          </a:xfrm>
-          <a:prstGeom prst="ellipse">
-            <a:avLst/>
-          </a:prstGeom>
-          <a:solidFill>
-            <a:srgbClr val="D64545"/>
-          </a:solidFill>
-          <a:ln w="12700">
-            <a:solidFill>
-              <a:srgbClr val="D64545"/>
-            </a:solidFill>
-            <a:prstDash val="solid"/>
-          </a:ln>
-        </p:spPr>
-      </p:sp>
-      <p:sp>
-        <p:nvSpPr>
-          <p:cNvPr id="12" name="last stand inset"/>
-          <p:cNvSpPr/>
-          <p:nvPr/>
-        </p:nvSpPr>
-        <p:spPr>
-          <a:xfrm>
-            <a:off x="2011680" y="1828800"/>
-            <a:ext cx="914400" cy="548640"/>
-          </a:xfrm>
-          <a:prstGeom prst="rect">
-            <a:avLst/>
-          </a:prstGeom>
-          <a:solidFill>
-            <a:srgbClr val="1B1F3B"/>
-          </a:solidFill>
-          <a:ln w="9525">
-            <a:solidFill>
-              <a:srgbClr val="C58A00"/>
-            </a:solidFill>
-            <a:prstDash val="solid"/>
-          </a:ln>
-        </p:spPr>
-      </p:sp>
-      <p:sp>
-        <p:nvSpPr>
-          <p:cNvPr id="13" name="last stand text"/>
-          <p:cNvSpPr txBox="1"/>
-          <p:nvPr/>
-        </p:nvSpPr>
-        <p:spPr>
-          <a:xfrm>
-            <a:off x="2011680" y="1828800"/>
-            <a:ext cx="914400" cy="548640"/>
-          </a:xfrm>
-          <a:prstGeom prst="rect">
-            <a:avLst/>
-          </a:prstGeom>
-          <a:noFill/>
-          <a:ln/>
-        </p:spPr>
-        <p:txBody>
-          <a:bodyPr wrap="square" lIns="50800" tIns="50800" rIns="50800" bIns="50800" rtlCol="0" anchor="ctr"/>
-          <a:lstStyle/>
-          <a:p>
-            <a:pPr algn="ctr" indent="0" marL="0">
-              <a:buNone/>
-            </a:pPr>
-            <a:r>
-              <a:rPr lang="en-US" sz="700" dirty="0">
-                <a:solidFill>
-                  <a:schemeClr val="accent1"/>
-                </a:solidFill>
-              </a:rPr>
-              <a:t>LAST STAND</a:t>
-            </a:r>
-            <a:endParaRPr lang="en-US" sz="700" dirty="0"/>
-          </a:p>
-          <a:p>
-            <a:pPr algn="ctr" indent="0" marL="0">
-              <a:buNone/>
-            </a:pPr>
-            <a:r>
-              <a:rPr lang="en-US" sz="700" dirty="0">
-                <a:solidFill>
-                  <a:schemeClr val="accent1"/>
-                </a:solidFill>
-              </a:rPr>
-              <a:t>coin flip</a:t>
-            </a:r>
-            <a:endParaRPr lang="en-US" sz="700" dirty="0"/>
-          </a:p>
-        </p:txBody>
-      </p:sp>
-      <p:sp>
-        <p:nvSpPr>
-          <p:cNvPr id="14" name="dispatch panel"/>
-          <p:cNvSpPr/>
-          <p:nvPr/>
-        </p:nvSpPr>
-        <p:spPr>
-          <a:xfrm>
-            <a:off x="1920240" y="3520440"/>
-            <a:ext cx="2514600" cy="822960"/>
-          </a:xfrm>
-          <a:prstGeom prst="rect">
-            <a:avLst/>
-          </a:prstGeom>
-          <a:solidFill>
-            <a:srgbClr val="2E3466"/>
-          </a:solidFill>
-          <a:ln w="12700">
-            <a:solidFill>
-              <a:srgbClr val="2E3466"/>
-            </a:solidFill>
-            <a:prstDash val="solid"/>
-          </a:ln>
-        </p:spPr>
-      </p:sp>
-      <p:sp>
-        <p:nvSpPr>
-          <p:cNvPr id="15" name="dispatch text"/>
-          <p:cNvSpPr txBox="1"/>
-          <p:nvPr/>
-        </p:nvSpPr>
-        <p:spPr>
-          <a:xfrm>
-            <a:off x="1920240" y="3520440"/>
-            <a:ext cx="2514600" cy="822960"/>
-          </a:xfrm>
-          <a:prstGeom prst="rect">
-            <a:avLst/>
-          </a:prstGeom>
-          <a:noFill/>
-          <a:ln/>
-        </p:spPr>
-        <p:txBody>
-          <a:bodyPr wrap="square" lIns="76200" tIns="76200" rIns="76200" bIns="76200" rtlCol="0" anchor="ctr"/>
-          <a:lstStyle/>
-          <a:p>
-            <a:pPr indent="0" marL="0">
-              <a:buNone/>
-            </a:pPr>
-            <a:r>
-              <a:rPr lang="en-US" sz="750" dirty="0">
-                <a:solidFill>
-                  <a:srgbClr val="CADCFC"/>
-                </a:solidFill>
-              </a:rPr>
-              <a:t>DISPATCH  ·  Scramble Jets  ·  Deploy Mechs  ·  Raise Barrier  ·  Evac Sector  ·  Citywide Alert</a:t>
-            </a:r>
-            <a:endParaRPr lang="en-US" sz="750" dirty="0"/>
-          </a:p>
-        </p:txBody>
-      </p:sp>
-      <p:sp>
-        <p:nvSpPr>
-          <p:cNvPr id="16" name="feed panel"/>
-          <p:cNvSpPr/>
-          <p:nvPr/>
-        </p:nvSpPr>
-        <p:spPr>
-          <a:xfrm>
-            <a:off x="4526280" y="1325880"/>
-            <a:ext cx="1005840" cy="3017520"/>
-          </a:xfrm>
-          <a:prstGeom prst="rect">
-            <a:avLst/>
-          </a:prstGeom>
-          <a:solidFill>
-            <a:srgbClr val="2E3466"/>
-          </a:solidFill>
-          <a:ln w="12700">
-            <a:solidFill>
-              <a:srgbClr val="2E3466"/>
-            </a:solidFill>
-            <a:prstDash val="solid"/>
-          </a:ln>
-        </p:spPr>
-      </p:sp>
-      <p:sp>
-        <p:nvSpPr>
-          <p:cNvPr id="17" name="feed text"/>
-          <p:cNvSpPr txBox="1"/>
-          <p:nvPr/>
-        </p:nvSpPr>
-        <p:spPr>
-          <a:xfrm>
-            <a:off x="4526280" y="1325880"/>
-            <a:ext cx="1005840" cy="3017520"/>
-          </a:xfrm>
-          <a:prstGeom prst="rect">
-            <a:avLst/>
-          </a:prstGeom>
-          <a:noFill/>
-          <a:ln/>
-        </p:spPr>
-        <p:txBody>
-          <a:bodyPr wrap="square" lIns="76200" tIns="76200" rIns="76200" bIns="76200" rtlCol="0" anchor="t"/>
-          <a:lstStyle/>
-          <a:p>
-            <a:pPr indent="0" marL="0">
-              <a:buNone/>
-            </a:pPr>
-            <a:r>
-              <a:rPr lang="en-US" sz="750" dirty="0">
-                <a:solidFill>
-                  <a:srgbClr val="CADCFC"/>
-                </a:solidFill>
-              </a:rPr>
-              <a:t>SIGNAL FEED</a:t>
-            </a:r>
-            <a:endParaRPr lang="en-US" sz="750" dirty="0"/>
-          </a:p>
-          <a:p>
-            <a:pPr indent="0" marL="0">
-              <a:buNone/>
-            </a:pPr>
-            <a:endParaRPr lang="en-US" sz="750" dirty="0"/>
-          </a:p>
-          <a:p>
-            <a:pPr indent="0" marL="0">
-              <a:buNone/>
-            </a:pPr>
-            <a:r>
-              <a:rPr lang="en-US" sz="750" dirty="0">
-                <a:solidFill>
-                  <a:srgbClr val="CADCFC"/>
-                </a:solidFill>
-              </a:rPr>
-              <a:t>12:04 sonar ping</a:t>
-            </a:r>
-            <a:endParaRPr lang="en-US" sz="750" dirty="0"/>
-          </a:p>
-          <a:p>
-            <a:pPr indent="0" marL="0">
-              <a:buNone/>
-            </a:pPr>
-            <a:r>
-              <a:rPr lang="en-US" sz="750" dirty="0">
-                <a:solidFill>
-                  <a:srgbClr val="CADCFC"/>
-                </a:solidFill>
-              </a:rPr>
-              <a:t>12:04 sensor 7</a:t>
-            </a:r>
-            <a:endParaRPr lang="en-US" sz="750" dirty="0"/>
-          </a:p>
-          <a:p>
-            <a:pPr indent="0" marL="0">
-              <a:buNone/>
-            </a:pPr>
-            <a:r>
-              <a:rPr lang="en-US" sz="750" dirty="0">
-                <a:solidFill>
-                  <a:srgbClr val="CADCFC"/>
-                </a:solidFill>
-              </a:rPr>
-              <a:t>12:05 report</a:t>
-            </a:r>
-            <a:endParaRPr lang="en-US" sz="750" dirty="0"/>
-          </a:p>
-          <a:p>
-            <a:pPr indent="0" marL="0">
-              <a:buNone/>
-            </a:pPr>
-            <a:r>
-              <a:rPr lang="en-US" sz="750" dirty="0">
-                <a:solidFill>
-                  <a:srgbClr val="CADCFC"/>
-                </a:solidFill>
-              </a:rPr>
-              <a:t>12:05 public</a:t>
-            </a:r>
-            <a:endParaRPr lang="en-US" sz="750" dirty="0"/>
-          </a:p>
-          <a:p>
-            <a:pPr indent="0" marL="0">
-              <a:buNone/>
-            </a:pPr>
-            <a:r>
-              <a:rPr lang="en-US" sz="750" dirty="0">
-                <a:solidFill>
-                  <a:srgbClr val="CADCFC"/>
-                </a:solidFill>
-              </a:rPr>
-              <a:t>12:06 ping</a:t>
-            </a:r>
-            <a:endParaRPr lang="en-US" sz="750" dirty="0"/>
-          </a:p>
-        </p:txBody>
-      </p:sp>
-      <p:sp>
-        <p:nvSpPr>
-          <p:cNvPr id="18" name="app claim"/>
+            <a:ext cx="5120640" cy="2880360"/>
+          </a:xfrm>
+          <a:prstGeom prst="rect">
+            <a:avLst/>
+          </a:prstGeom>
+        </p:spPr>
+      </p:pic>
+      <p:sp>
+        <p:nvSpPr>
+          <p:cNvPr id="4" name="shot caption"/>
+          <p:cNvSpPr txBox="1"/>
+          <p:nvPr/>
+        </p:nvSpPr>
+        <p:spPr>
+          <a:xfrm>
+            <a:off x="548640" y="4114800"/>
+            <a:ext cx="5120640" cy="274320"/>
+          </a:xfrm>
+          <a:prstGeom prst="rect">
+            <a:avLst/>
+          </a:prstGeom>
+          <a:noFill/>
+          <a:ln/>
+        </p:spPr>
+        <p:txBody>
+          <a:bodyPr wrap="square" lIns="0" tIns="0" rIns="0" bIns="0" rtlCol="0" anchor="ctr"/>
+          <a:lstStyle/>
+          <a:p>
+            <a:pPr indent="0" marL="0">
+              <a:buNone/>
+            </a:pPr>
+            <a:r>
+              <a:rPr lang="en-US" sz="1000" dirty="0">
+                <a:solidFill>
+                  <a:schemeClr val="accent5"/>
+                </a:solidFill>
+              </a:rPr>
+              <a:t>Hosted demo, live</a:t>
+            </a:r>
+            <a:endParaRPr lang="en-US" sz="1000" dirty="0"/>
+          </a:p>
+        </p:txBody>
+      </p:sp>
+      <p:sp>
+        <p:nvSpPr>
+          <p:cNvPr id="5" name="app claim"/>
           <p:cNvSpPr txBox="1"/>
           <p:nvPr/>
         </p:nvSpPr>
@@ -3652,7 +2942,7 @@
       </p:sp>
       <p:sp>
         <p:nvSpPr>
-          <p:cNvPr id="19" name="app points"/>
+          <p:cNvPr id="6" name="app points"/>
           <p:cNvSpPr txBox="1"/>
           <p:nvPr/>
         </p:nvSpPr>
@@ -3746,7 +3036,7 @@
       </p:sp>
       <p:sp>
         <p:nvSpPr>
-          <p:cNvPr id="20" name="app source"/>
+          <p:cNvPr id="7" name="app source"/>
           <p:cNvSpPr txBox="1"/>
           <p:nvPr/>
         </p:nvSpPr>
@@ -4406,34 +3696,9 @@
           </a:ln>
         </p:spPr>
       </p:sp>
-      <p:sp>
-        <p:nvSpPr>
-          <p:cNvPr id="19" name="scen4 circle"/>
-          <p:cNvSpPr/>
-          <p:nvPr/>
-        </p:nvSpPr>
-        <p:spPr>
-          <a:xfrm>
-            <a:off x="4846320" y="3108960"/>
-            <a:ext cx="502920" cy="502920"/>
-          </a:xfrm>
-          <a:prstGeom prst="ellipse">
-            <a:avLst/>
-          </a:prstGeom>
-          <a:solidFill>
-            <a:srgbClr val="3B3F8C"/>
-          </a:solidFill>
-          <a:ln w="12700">
-            <a:solidFill>
-              <a:srgbClr val="3B3F8C"/>
-            </a:solidFill>
-            <a:prstDash val="solid"/>
-          </a:ln>
-        </p:spPr>
-      </p:sp>
       <p:pic>
         <p:nvPicPr>
-          <p:cNvPr id="20" name="scen4 icon" descr="preencoded.png">    </p:cNvPr>
+          <p:cNvPr id="19" name="monster 4" descr="preencoded.png">    </p:cNvPr>
           <p:cNvPicPr>
             <a:picLocks noChangeAspect="1"/>
           </p:cNvPicPr>
@@ -4447,8 +3712,8 @@
         </p:blipFill>
         <p:spPr>
           <a:xfrm>
-            <a:off x="4977079" y="3239719"/>
-            <a:ext cx="241402" cy="241402"/>
+            <a:off x="4800600" y="3035808"/>
+            <a:ext cx="621792" cy="621792"/>
           </a:xfrm>
           <a:prstGeom prst="rect">
             <a:avLst/>
@@ -4457,7 +3722,7 @@
       </p:pic>
       <p:sp>
         <p:nvSpPr>
-          <p:cNvPr id="21" name="scen name 4"/>
+          <p:cNvPr id="20" name="scen name 4"/>
           <p:cNvSpPr txBox="1"/>
           <p:nvPr/>
         </p:nvSpPr>
@@ -4493,7 +3758,7 @@
       </p:sp>
       <p:sp>
         <p:nvSpPr>
-          <p:cNvPr id="22" name="scen meta 4"/>
+          <p:cNvPr id="21" name="scen meta 4"/>
           <p:cNvSpPr txBox="1"/>
           <p:nvPr/>
         </p:nvSpPr>
@@ -4529,7 +3794,7 @@
       </p:sp>
       <p:sp>
         <p:nvSpPr>
-          <p:cNvPr id="23" name="scen choice 4"/>
+          <p:cNvPr id="22" name="scen choice 4"/>
           <p:cNvSpPr txBox="1"/>
           <p:nvPr/>
         </p:nvSpPr>
@@ -4871,7 +4136,7 @@
                   <a:schemeClr val="bg1"/>
                 </a:solidFill>
               </a:rPr>
-              <a:t>No screen of your own</a:t>
+              <a:t>Your only screen is the command centre</a:t>
             </a:r>
             <a:endParaRPr lang="en-US" sz="1700" dirty="0"/>
           </a:p>
@@ -4907,7 +4172,7 @@
                   <a:srgbClr val="CADCFC"/>
                 </a:solidFill>
               </a:rPr>
-              <a:t>You see only what the specialists report, when they report it. Nine of them have already been interviewed.</a:t>
+              <a:t>Everything else reaches you by report, when the specialists report it. Nine of them have already been interviewed.</a:t>
             </a:r>
             <a:endParaRPr lang="en-US" sz="1250" dirty="0"/>
           </a:p>

</xml_diff>